<commit_message>
docs: update flaskserver + hscdownloader docs and slides for the security/robustness changes
Reflect the eight code changes across the developer reference (documentation/), the layman guides (presentation/), the Security Model deck, the known-issues tracker, and the regenerated .pptx decks: X-Session-ID allow-list on the Parylene batch endpoints, room_id keep-or-update in update_container, defensive int() on chem query params, raw-password hashing (no sanitizer) with legacy fallback, Flask-WTF CSRF protection, secure-by-default config + fail-closed SECRET_KEY, HSCDownloader per-machine isolation + request timeout, and admin self-delete / last-admin lockout guards. Regenerated 7 flaskserver decks + the HSC-Downloader tooldeck from their _build sources. Adds a .gitignore rule for slide build artifacts (node_modules / out / package files).
</commit_message>
<xml_diff>
--- a/presentation/UNanofabTools/flaskserver/slides/02-How-It-Starts.pptx
+++ b/presentation/UNanofabTools/flaskserver/slides/02-How-It-Starts.pptx
@@ -864,7 +864,7 @@
           <a:p>
             <a:r>
               <a:rPr lang="en-US" dirty="0"/>
-              <a:t>Walk it in plain words. Line 1: look up an environment setting called FLASK_ENV to decide whether we're in 'development' or 'production' mode; default to development. Line 2: call create_app — that's the factory that assembles everything. The 'if' block at the bottom only runs when you launch this file directly (handy for local testing); in real production a separate, sturdier web server loads the app instead. The headline: run.py decides the mode, then hands off to the factory.</a:t>
+              <a:t>Walk it in plain words. Line 1: look up an environment setting called FLASK_ENV to decide whether we're in 'development' or 'production' mode; it defaults to production, so a missing or misspelled value fails safe (2FA on, secure cookies) instead of quietly dropping into the looser dev settings — local development sets FLASK_ENV=development on purpose. Line 2: call create_app — that's the factory that assembles everything. The 'if' block at the bottom only runs when you launch this file directly (handy for local testing); in real production a separate, sturdier web server loads the app instead. The headline: run.py decides the mode, then hands off to the factory.</a:t>
             </a:r>
             <a:endParaRPr lang="en-US" dirty="0"/>
           </a:p>
@@ -3303,7 +3303,7 @@
                 <a:ea typeface="Consolas" pitchFamily="34" charset="-122"/>
                 <a:cs typeface="Consolas" pitchFamily="34" charset="-120"/>
               </a:rPr>
-              <a:t>config_name = os.getenv('FLASK_ENV', 'development')</a:t>
+              <a:t>config_name = os.getenv('FLASK_ENV', 'production')</a:t>
             </a:r>
             <a:endParaRPr lang="en-US" sz="1250" dirty="0"/>
           </a:p>

</xml_diff>